<commit_message>
Arm imbalance summary deck: GSG simple schematic, larger INTERCONNECT schematic, trapezoid ribs with over-etched slab
Co-Authored-By: Claude Opus 5.5 <noreply@anthropic.com>
Claude-Session: https://claude.ai/code/session_01PF7RKNjFsSkyjm1syGCUrV
</commit_message>
<xml_diff>
--- a/docs/Arm_imbalances_summary.pptx
+++ b/docs/Arm_imbalances_summary.pptx
@@ -5958,8 +5958,8 @@
         </p:blipFill>
         <p:spPr>
           <a:xfrm>
-            <a:off x="457200" y="1465729"/>
-            <a:ext cx="3566160" cy="2097741"/>
+            <a:off x="457200" y="1502923"/>
+            <a:ext cx="3566160" cy="2023353"/>
           </a:xfrm>
           <a:prstGeom prst="rect">
             <a:avLst/>
@@ -8375,8 +8375,8 @@
         </p:nvSpPr>
         <p:spPr>
           <a:xfrm>
-            <a:off x="457200" y="1463040"/>
-            <a:ext cx="5120640" cy="4160520"/>
+            <a:off x="457200" y="1417320"/>
+            <a:ext cx="3611880" cy="2057400"/>
           </a:xfrm>
           <a:prstGeom prst="roundRect">
             <a:avLst>
@@ -8431,8 +8431,8 @@
         </p:blipFill>
         <p:spPr>
           <a:xfrm>
-            <a:off x="548640" y="1807196"/>
-            <a:ext cx="4937760" cy="2329206"/>
+            <a:off x="502919" y="1507703"/>
+            <a:ext cx="3520440" cy="1876632"/>
           </a:xfrm>
           <a:prstGeom prst="rect">
             <a:avLst/>
@@ -8447,8 +8447,8 @@
         </p:nvSpPr>
         <p:spPr>
           <a:xfrm>
-            <a:off x="5806440" y="1463040"/>
-            <a:ext cx="5943600" cy="4160520"/>
+            <a:off x="4206240" y="1417320"/>
+            <a:ext cx="7543800" cy="4251960"/>
           </a:xfrm>
           <a:prstGeom prst="roundRect">
             <a:avLst>
@@ -8503,8 +8503,8 @@
         </p:blipFill>
         <p:spPr>
           <a:xfrm>
-            <a:off x="5897880" y="1974323"/>
-            <a:ext cx="5760720" cy="3137953"/>
+            <a:off x="4251960" y="1513592"/>
+            <a:ext cx="7452360" cy="4059415"/>
           </a:xfrm>
           <a:prstGeom prst="rect">
             <a:avLst/>
@@ -8513,14 +8513,60 @@
       </p:pic>
       <p:sp>
         <p:nvSpPr>
-          <p:cNvPr id="8" name="TextBox 7"/>
+          <p:cNvPr id="8" name="Rounded Rectangle 7"/>
+          <p:cNvSpPr/>
+          <p:nvPr/>
+        </p:nvSpPr>
+        <p:spPr>
+          <a:xfrm>
+            <a:off x="457200" y="3611880"/>
+            <a:ext cx="3611880" cy="1143000"/>
+          </a:xfrm>
+          <a:prstGeom prst="roundRect">
+            <a:avLst>
+              <a:gd name="adj" fmla="val 6000"/>
+            </a:avLst>
+          </a:prstGeom>
+          <a:solidFill>
+            <a:srgbClr val="F1F3F8"/>
+          </a:solidFill>
+          <a:ln>
+            <a:noFill/>
+          </a:ln>
+          <a:effectLst/>
+        </p:spPr>
+        <p:style>
+          <a:lnRef idx="1">
+            <a:schemeClr val="accent1"/>
+          </a:lnRef>
+          <a:fillRef idx="3">
+            <a:schemeClr val="accent1"/>
+          </a:fillRef>
+          <a:effectRef idx="2">
+            <a:schemeClr val="accent1"/>
+          </a:effectRef>
+          <a:fontRef idx="minor">
+            <a:schemeClr val="lt1"/>
+          </a:fontRef>
+        </p:style>
+        <p:txBody>
+          <a:bodyPr rtlCol="0" anchor="ctr"/>
+          <a:lstStyle/>
+          <a:p>
+            <a:pPr algn="ctr"/>
+          </a:p>
+        </p:txBody>
+      </p:sp>
+      <p:sp>
+        <p:nvSpPr>
+          <p:cNvPr id="9" name="TextBox 8"/>
           <p:cNvSpPr txBox="1"/>
           <p:nvPr/>
         </p:nvSpPr>
         <p:spPr>
           <a:xfrm>
-            <a:off x="685800" y="4434840"/>
-            <a:ext cx="2468880" cy="320040"/>
+            <a:off x="566928" y="3657600"/>
+            <a:ext cx="3429000" cy="1051560"/>
           </a:xfrm>
           <a:prstGeom prst="rect">
             <a:avLst/>
@@ -8535,40 +8581,47 @@
           <a:p>
             <a:pPr algn="l">
               <a:spcAft>
-                <a:spcPts val="400"/>
+                <a:spcPts val="200"/>
               </a:spcAft>
             </a:pPr>
             <a:r>
-              <a:rPr sz="1050" b="1" i="0">
+              <a:rPr sz="1250" b="1" i="0">
+                <a:solidFill>
+                  <a:srgbClr val="0E2268"/>
+                </a:solidFill>
+                <a:latin typeface="Arial"/>
+              </a:rPr>
+              <a:t>One GSG line → two TW blocks</a:t>
+            </a:r>
+          </a:p>
+          <a:p>
+            <a:pPr algn="l">
+              <a:spcAft>
+                <a:spcPts val="200"/>
+              </a:spcAft>
+            </a:pPr>
+            <a:r>
+              <a:rPr sz="1050" b="0" i="0">
                 <a:solidFill>
                   <a:srgbClr val="1A1A1A"/>
                 </a:solidFill>
                 <a:latin typeface="Arial"/>
               </a:rPr>
-              <a:t>CWL_1</a:t>
-            </a:r>
-            <a:r>
-              <a:rPr sz="1050" b="0" i="0">
-                <a:solidFill>
-                  <a:srgbClr val="1A1A1A"/>
-                </a:solidFill>
-                <a:latin typeface="Arial"/>
-              </a:rPr>
-              <a:t>  laser</a:t>
-            </a:r>
-          </a:p>
-        </p:txBody>
-      </p:sp>
-      <p:sp>
-        <p:nvSpPr>
-          <p:cNvPr id="9" name="TextBox 8"/>
+              <a:t>Each arm sits in one S–G gap. Same line, same drive, opposite field: TW_1/OM_1 = gap 1, TW_2/OM_2 = gap 2.</a:t>
+            </a:r>
+          </a:p>
+        </p:txBody>
+      </p:sp>
+      <p:sp>
+        <p:nvSpPr>
+          <p:cNvPr id="10" name="TextBox 9"/>
           <p:cNvSpPr txBox="1"/>
           <p:nvPr/>
         </p:nvSpPr>
         <p:spPr>
           <a:xfrm>
-            <a:off x="3154680" y="4434840"/>
-            <a:ext cx="2468880" cy="320040"/>
+            <a:off x="502920" y="4846320"/>
+            <a:ext cx="3566160" cy="201168"/>
           </a:xfrm>
           <a:prstGeom prst="rect">
             <a:avLst/>
@@ -8583,40 +8636,40 @@
           <a:p>
             <a:pPr algn="l">
               <a:spcAft>
-                <a:spcPts val="400"/>
+                <a:spcPts val="0"/>
               </a:spcAft>
             </a:pPr>
             <a:r>
-              <a:rPr sz="1050" b="1" i="0">
+              <a:rPr sz="950" b="1" i="0">
                 <a:solidFill>
                   <a:srgbClr val="1A1A1A"/>
                 </a:solidFill>
                 <a:latin typeface="Arial"/>
               </a:rPr>
-              <a:t>SPLT_1 / SPLT_2</a:t>
-            </a:r>
-            <a:r>
-              <a:rPr sz="1050" b="0" i="0">
+              <a:t>CWL_1</a:t>
+            </a:r>
+            <a:r>
+              <a:rPr sz="950" b="0" i="0">
                 <a:solidFill>
                   <a:srgbClr val="1A1A1A"/>
                 </a:solidFill>
                 <a:latin typeface="Arial"/>
               </a:rPr>
-              <a:t>  Y splitter / combiner</a:t>
-            </a:r>
-          </a:p>
-        </p:txBody>
-      </p:sp>
-      <p:sp>
-        <p:nvSpPr>
-          <p:cNvPr id="10" name="TextBox 9"/>
+              <a:t>  laser</a:t>
+            </a:r>
+          </a:p>
+        </p:txBody>
+      </p:sp>
+      <p:sp>
+        <p:nvSpPr>
+          <p:cNvPr id="11" name="TextBox 10"/>
           <p:cNvSpPr txBox="1"/>
           <p:nvPr/>
         </p:nvSpPr>
         <p:spPr>
           <a:xfrm>
-            <a:off x="685800" y="4800600"/>
-            <a:ext cx="2468880" cy="320040"/>
+            <a:off x="502920" y="5020056"/>
+            <a:ext cx="3566160" cy="201168"/>
           </a:xfrm>
           <a:prstGeom prst="rect">
             <a:avLst/>
@@ -8631,40 +8684,40 @@
           <a:p>
             <a:pPr algn="l">
               <a:spcAft>
-                <a:spcPts val="400"/>
+                <a:spcPts val="0"/>
               </a:spcAft>
             </a:pPr>
             <a:r>
-              <a:rPr sz="1050" b="1" i="0">
+              <a:rPr sz="950" b="1" i="0">
                 <a:solidFill>
                   <a:srgbClr val="1A1A1A"/>
                 </a:solidFill>
                 <a:latin typeface="Arial"/>
               </a:rPr>
-              <a:t>TW_1, TW_2</a:t>
-            </a:r>
-            <a:r>
-              <a:rPr sz="1050" b="0" i="0">
+              <a:t>SPLT_1/2</a:t>
+            </a:r>
+            <a:r>
+              <a:rPr sz="950" b="0" i="0">
                 <a:solidFill>
                   <a:srgbClr val="1A1A1A"/>
                 </a:solidFill>
                 <a:latin typeface="Arial"/>
               </a:rPr>
-              <a:t>  travelling-wave electrode, one per arm</a:t>
-            </a:r>
-          </a:p>
-        </p:txBody>
-      </p:sp>
-      <p:sp>
-        <p:nvSpPr>
-          <p:cNvPr id="11" name="TextBox 10"/>
+              <a:t>  Y splitter / combiner</a:t>
+            </a:r>
+          </a:p>
+        </p:txBody>
+      </p:sp>
+      <p:sp>
+        <p:nvSpPr>
+          <p:cNvPr id="12" name="TextBox 11"/>
           <p:cNvSpPr txBox="1"/>
           <p:nvPr/>
         </p:nvSpPr>
         <p:spPr>
           <a:xfrm>
-            <a:off x="3154680" y="4800600"/>
-            <a:ext cx="2468880" cy="320040"/>
+            <a:off x="502920" y="5193792"/>
+            <a:ext cx="3566160" cy="201168"/>
           </a:xfrm>
           <a:prstGeom prst="rect">
             <a:avLst/>
@@ -8679,40 +8732,40 @@
           <a:p>
             <a:pPr algn="l">
               <a:spcAft>
-                <a:spcPts val="400"/>
+                <a:spcPts val="0"/>
               </a:spcAft>
             </a:pPr>
             <a:r>
-              <a:rPr sz="1050" b="1" i="0">
+              <a:rPr sz="950" b="1" i="0">
                 <a:solidFill>
                   <a:srgbClr val="1A1A1A"/>
                 </a:solidFill>
                 <a:latin typeface="Arial"/>
               </a:rPr>
-              <a:t>OM_1, OM_2</a:t>
-            </a:r>
-            <a:r>
-              <a:rPr sz="1050" b="0" i="0">
+              <a:t>TW_1/2 + OM_1/2</a:t>
+            </a:r>
+            <a:r>
+              <a:rPr sz="950" b="0" i="0">
                 <a:solidFill>
                   <a:srgbClr val="1A1A1A"/>
                 </a:solidFill>
                 <a:latin typeface="Arial"/>
               </a:rPr>
-              <a:t>  phase modulator, one per arm</a:t>
-            </a:r>
-          </a:p>
-        </p:txBody>
-      </p:sp>
-      <p:sp>
-        <p:nvSpPr>
-          <p:cNvPr id="12" name="TextBox 11"/>
+              <a:t>  electrode gap + phase modulation</a:t>
+            </a:r>
+          </a:p>
+        </p:txBody>
+      </p:sp>
+      <p:sp>
+        <p:nvSpPr>
+          <p:cNvPr id="13" name="TextBox 12"/>
           <p:cNvSpPr txBox="1"/>
           <p:nvPr/>
         </p:nvSpPr>
         <p:spPr>
           <a:xfrm>
-            <a:off x="685800" y="5166359"/>
-            <a:ext cx="2468880" cy="320040"/>
+            <a:off x="502920" y="5367528"/>
+            <a:ext cx="3566160" cy="201168"/>
           </a:xfrm>
           <a:prstGeom prst="rect">
             <a:avLst/>
@@ -8727,11 +8780,11 @@
           <a:p>
             <a:pPr algn="l">
               <a:spcAft>
-                <a:spcPts val="400"/>
+                <a:spcPts val="0"/>
               </a:spcAft>
             </a:pPr>
             <a:r>
-              <a:rPr sz="1050" b="1" i="0">
+              <a:rPr sz="950" b="1" i="0">
                 <a:solidFill>
                   <a:srgbClr val="1A1A1A"/>
                 </a:solidFill>
@@ -8740,27 +8793,27 @@
               <a:t>PHS_1</a:t>
             </a:r>
             <a:r>
-              <a:rPr sz="1050" b="0" i="0">
+              <a:rPr sz="950" b="0" i="0">
                 <a:solidFill>
                   <a:srgbClr val="1A1A1A"/>
                 </a:solidFill>
                 <a:latin typeface="Arial"/>
               </a:rPr>
-              <a:t>  bias phase (quadrature)</a:t>
-            </a:r>
-          </a:p>
-        </p:txBody>
-      </p:sp>
-      <p:sp>
-        <p:nvSpPr>
-          <p:cNvPr id="13" name="TextBox 12"/>
+              <a:t>  bias (quadrature)</a:t>
+            </a:r>
+          </a:p>
+        </p:txBody>
+      </p:sp>
+      <p:sp>
+        <p:nvSpPr>
+          <p:cNvPr id="14" name="TextBox 13"/>
           <p:cNvSpPr txBox="1"/>
           <p:nvPr/>
         </p:nvSpPr>
         <p:spPr>
           <a:xfrm>
-            <a:off x="3154680" y="5166359"/>
-            <a:ext cx="2468880" cy="320040"/>
+            <a:off x="502920" y="5541264"/>
+            <a:ext cx="3566160" cy="201168"/>
           </a:xfrm>
           <a:prstGeom prst="rect">
             <a:avLst/>
@@ -8775,11 +8828,11 @@
           <a:p>
             <a:pPr algn="l">
               <a:spcAft>
-                <a:spcPts val="400"/>
+                <a:spcPts val="0"/>
               </a:spcAft>
             </a:pPr>
             <a:r>
-              <a:rPr sz="1050" b="1" i="0">
+              <a:rPr sz="950" b="1" i="0">
                 <a:solidFill>
                   <a:srgbClr val="1A1A1A"/>
                 </a:solidFill>
@@ -8788,7 +8841,7 @@
               <a:t>PIN_1</a:t>
             </a:r>
             <a:r>
-              <a:rPr sz="1050" b="0" i="0">
+              <a:rPr sz="950" b="0" i="0">
                 <a:solidFill>
                   <a:srgbClr val="1A1A1A"/>
                 </a:solidFill>
@@ -8801,13 +8854,13 @@
       </p:sp>
       <p:sp>
         <p:nvSpPr>
-          <p:cNvPr id="14" name="TextBox 13"/>
+          <p:cNvPr id="15" name="TextBox 14"/>
           <p:cNvSpPr txBox="1"/>
           <p:nvPr/>
         </p:nvSpPr>
         <p:spPr>
           <a:xfrm>
-            <a:off x="457200" y="5806440"/>
+            <a:off x="457200" y="5852160"/>
             <a:ext cx="11292840" cy="365760"/>
           </a:xfrm>
           <a:prstGeom prst="rect">
@@ -9566,8 +9619,8 @@
         </p:blipFill>
         <p:spPr>
           <a:xfrm>
-            <a:off x="3886200" y="1638123"/>
-            <a:ext cx="4297680" cy="2027272"/>
+            <a:off x="4062382" y="1600200"/>
+            <a:ext cx="3945314" cy="2103120"/>
           </a:xfrm>
           <a:prstGeom prst="rect">
             <a:avLst/>
@@ -10324,8 +10377,8 @@
         </p:blipFill>
         <p:spPr>
           <a:xfrm>
-            <a:off x="3886200" y="1638123"/>
-            <a:ext cx="4297680" cy="2027272"/>
+            <a:off x="4062382" y="1600200"/>
+            <a:ext cx="3945314" cy="2103120"/>
           </a:xfrm>
           <a:prstGeom prst="rect">
             <a:avLst/>
@@ -11082,8 +11135,8 @@
         </p:blipFill>
         <p:spPr>
           <a:xfrm>
-            <a:off x="3886200" y="1638123"/>
-            <a:ext cx="4297680" cy="2027272"/>
+            <a:off x="4062382" y="1600200"/>
+            <a:ext cx="3945314" cy="2103120"/>
           </a:xfrm>
           <a:prstGeom prst="rect">
             <a:avLst/>
@@ -11858,8 +11911,8 @@
         </p:blipFill>
         <p:spPr>
           <a:xfrm>
-            <a:off x="3886200" y="1638123"/>
-            <a:ext cx="4297680" cy="2027272"/>
+            <a:off x="4062382" y="1600200"/>
+            <a:ext cx="3945314" cy="2103120"/>
           </a:xfrm>
           <a:prstGeom prst="rect">
             <a:avLst/>
@@ -12514,8 +12567,8 @@
         </p:blipFill>
         <p:spPr>
           <a:xfrm>
-            <a:off x="570699" y="1645920"/>
-            <a:ext cx="3064840" cy="1874519"/>
+            <a:off x="547268" y="1645920"/>
+            <a:ext cx="3111703" cy="1874519"/>
           </a:xfrm>
           <a:prstGeom prst="rect">
             <a:avLst/>
@@ -12616,8 +12669,8 @@
         </p:blipFill>
         <p:spPr>
           <a:xfrm>
-            <a:off x="3886200" y="1638123"/>
-            <a:ext cx="4297680" cy="2027272"/>
+            <a:off x="4062382" y="1600200"/>
+            <a:ext cx="3945314" cy="2103120"/>
           </a:xfrm>
           <a:prstGeom prst="rect">
             <a:avLst/>
@@ -13392,8 +13445,8 @@
         </p:blipFill>
         <p:spPr>
           <a:xfrm>
-            <a:off x="3886200" y="1638123"/>
-            <a:ext cx="4297680" cy="2027272"/>
+            <a:off x="4062382" y="1600200"/>
+            <a:ext cx="3945314" cy="2103120"/>
           </a:xfrm>
           <a:prstGeom prst="rect">
             <a:avLst/>

</xml_diff>